<commit_message>
Day 1: preview the capstone project (per Pradeep review)
Plant the capstone seed on Day 1 so attendees marinate on scenarios
all week instead of scoping cold on Day 5.

Changes:
- Module 7: new slide 'Preview: your capstone project' inserted right
  before the takeaways. Two columns: The format (solo/2-3, timing,
  1:1 review, coaching not scoring) + Required elements mapped to
  each day of the workshop. Bottom callout points at reflection Q4
  as the starter.
- Module 7 takeaways: added a 4th bullet 'Start noodling on your
  capstone scenario this week.'
- Lab reflection question 4 rewritten to explicitly ask for 2-3
  candidate capstone scenarios instead of the previous open-ended
  'what would you want to try next?'
- Markdown source and speaker notes kept in sync.

Module 7 slide count: 9 -> 10.
Time impact on Day 1 live: +3 min in Module 7.

Co-authored-by: Copilot <223556219+Copilot@users.noreply.github.com>
</commit_message>
<xml_diff>
--- a/decks/day1/module-7-lab-kickoff.pptx
+++ b/decks/day1/module-7-lab-kickoff.pptx
@@ -14,9 +14,10 @@
     <p:sldId id="262" r:id="rId8"/>
     <p:sldId id="263" r:id="rId9"/>
     <p:sldId id="264" r:id="rId10"/>
+    <p:sldId id="265" r:id="rId11"/>
   </p:sldIdLst>
   <p:notesMasterIdLst>
-    <p:notesMasterId r:id="rId11"/>
+    <p:notesMasterId r:id="rId12"/>
   </p:notesMasterIdLst>
   <p:sldSz cx="9144000" cy="5143500"/>
   <p:notesSz cx="5143500" cy="9144000"/>
@@ -555,6 +556,97 @@
 </p:notes>
 </file>
 
+<file path=ppt/notesSlides/notesSlide10.xml><?xml version="1.0" encoding="utf-8"?>
+<p:notes xmlns:a="http://schemas.openxmlformats.org/drawingml/2006/main" xmlns:r="http://schemas.openxmlformats.org/officeDocument/2006/relationships" xmlns:p="http://schemas.openxmlformats.org/presentationml/2006/main">
+  <p:cSld>
+    <p:spTree>
+      <p:nvGrpSpPr>
+        <p:cNvPr id="1" name=""/>
+        <p:cNvGrpSpPr/>
+        <p:nvPr/>
+      </p:nvGrpSpPr>
+      <p:grpSpPr>
+        <a:xfrm>
+          <a:off x="0" y="0"/>
+          <a:ext cx="0" cy="0"/>
+          <a:chOff x="0" y="0"/>
+          <a:chExt cx="0" cy="0"/>
+        </a:xfrm>
+      </p:grpSpPr>
+      <p:sp>
+        <p:nvSpPr>
+          <p:cNvPr id="2" name="Slide Image Placeholder 1"/>
+          <p:cNvSpPr>
+            <a:spLocks noGrp="1" noRot="1" noChangeAspect="1"/>
+          </p:cNvSpPr>
+          <p:nvPr>
+            <p:ph type="sldImg"/>
+          </p:nvPr>
+        </p:nvSpPr>
+        <p:spPr/>
+      </p:sp>
+      <p:sp>
+        <p:nvSpPr>
+          <p:cNvPr id="3" name="Notes Placeholder 2"/>
+          <p:cNvSpPr>
+            <a:spLocks noGrp="1"/>
+          </p:cNvSpPr>
+          <p:nvPr>
+            <p:ph type="body" idx="1"/>
+          </p:nvPr>
+        </p:nvSpPr>
+        <p:spPr/>
+        <p:txBody>
+          <a:bodyPr/>
+          <a:lstStyle/>
+          <a:p>
+            <a:r>
+              <a:rPr lang="en-US" dirty="0"/>
+              <a:t>• Sign-off · Day 1 wrap
+• Encourage attendees to start the lab in a small pair or group if async time doesn't line up individually
+• Reinforce the capstone seed one more time
+• Confirm no vocabulary confusion (Prompt agent / Hosted agent / Path C) before releasing</a:t>
+            </a:r>
+            <a:endParaRPr lang="en-US" dirty="0"/>
+          </a:p>
+        </p:txBody>
+      </p:sp>
+      <p:sp>
+        <p:nvSpPr>
+          <p:cNvPr id="4" name="Slide Number Placeholder 3"/>
+          <p:cNvSpPr>
+            <a:spLocks noGrp="1"/>
+          </p:cNvSpPr>
+          <p:nvPr>
+            <p:ph type="sldNum" sz="quarter" idx="10"/>
+          </p:nvPr>
+        </p:nvSpPr>
+        <p:spPr/>
+        <p:txBody>
+          <a:bodyPr/>
+          <a:lstStyle/>
+          <a:p>
+            <a:fld id="{F7021451-1387-4CA6-816F-3879F97B5CBC}" type="slidenum">
+              <a:rPr lang="en-US"/>
+              <a:t>10</a:t>
+            </a:fld>
+            <a:endParaRPr lang="en-US"/>
+          </a:p>
+        </p:txBody>
+      </p:sp>
+    </p:spTree>
+    <p:extLst>
+      <p:ext uri="{BB962C8B-B14F-4D97-AF65-F5344CB8AC3E}">
+        <p14:creationId xmlns:p14="http://schemas.microsoft.com/office/powerpoint/2010/main" val="1024086991"/>
+      </p:ext>
+    </p:extLst>
+  </p:cSld>
+  <p:clrMapOvr>
+    <a:masterClrMapping/>
+  </p:clrMapOvr>
+</p:notes>
+</file>
+
 <file path=ppt/notesSlides/notesSlide2.xml><?xml version="1.0" encoding="utf-8"?>
 <p:notes xmlns:a="http://schemas.openxmlformats.org/drawingml/2006/main" xmlns:r="http://schemas.openxmlformats.org/officeDocument/2006/relationships" xmlns:p="http://schemas.openxmlformats.org/presentationml/2006/main">
   <p:cSld>
@@ -1251,7 +1343,19 @@
           <a:p>
             <a:r>
               <a:rPr lang="en-US" dirty="0"/>
-              <a:t>Sign-off. Encourage attendees to start the lab in a small pair or group if the async time doesn't line up individually.</a:t>
+              <a:t>• Plant the seed on Day 1 — attendees have all week to marinate on scenarios
+• Emphasize: solo OR small teams of 2–3, their choice
+• Timing: capstone runs ~4–6 weeks after workshop close
+• Cohort 1 target: reviews complete by end of Nov 2026 (before blackout)
+• 1:1 review is coaching, not scoring — reassure any nervous attendees
+• Every required element maps to a day of the workshop:
+•   MAF agent → Day 1
+•   Grounding + tools → Day 2
+•   MCP / production shape → Day 3
+•   Multi-agent + eval → Day 4
+•   Observability + deployment → Day 5
+• Point out reflection question 4 explicitly — it's the seed
+• Ask attendees to jot down 2–3 scenario ideas by end of the week</a:t>
             </a:r>
             <a:endParaRPr lang="en-US" dirty="0"/>
           </a:p>
@@ -1788,6 +1892,315 @@
 </p:sld>
 </file>
 
+<file path=ppt/slides/slide10.xml><?xml version="1.0" encoding="utf-8"?>
+<p:sld xmlns:a="http://schemas.openxmlformats.org/drawingml/2006/main" xmlns:r="http://schemas.openxmlformats.org/officeDocument/2006/relationships" xmlns:p="http://schemas.openxmlformats.org/presentationml/2006/main">
+  <p:cSld name="Slide 10">
+    <p:bg>
+      <p:bgPr>
+        <a:solidFill>
+          <a:srgbClr val="FFFFFF"/>
+        </a:solidFill>
+      </p:bgPr>
+    </p:bg>
+    <p:spTree>
+      <p:nvGrpSpPr>
+        <p:cNvPr id="1" name=""/>
+        <p:cNvGrpSpPr/>
+        <p:nvPr/>
+      </p:nvGrpSpPr>
+      <p:grpSpPr>
+        <a:xfrm>
+          <a:off x="0" y="0"/>
+          <a:ext cx="0" cy="0"/>
+          <a:chOff x="0" y="0"/>
+          <a:chExt cx="0" cy="0"/>
+        </a:xfrm>
+      </p:grpSpPr>
+      <p:sp>
+        <p:nvSpPr>
+          <p:cNvPr id="2" name="Shape 0"/>
+          <p:cNvSpPr/>
+          <p:nvPr/>
+        </p:nvSpPr>
+        <p:spPr>
+          <a:xfrm>
+            <a:off x="0" y="0"/>
+            <a:ext cx="54864" cy="5143500"/>
+          </a:xfrm>
+          <a:prstGeom prst="rect">
+            <a:avLst/>
+          </a:prstGeom>
+          <a:solidFill>
+            <a:srgbClr val="1E2761"/>
+          </a:solidFill>
+          <a:ln/>
+        </p:spPr>
+      </p:sp>
+      <p:sp>
+        <p:nvSpPr>
+          <p:cNvPr id="3" name="Text 1"/>
+          <p:cNvSpPr/>
+          <p:nvPr/>
+        </p:nvSpPr>
+        <p:spPr>
+          <a:xfrm>
+            <a:off x="5669280" y="274320"/>
+            <a:ext cx="3291840" cy="274320"/>
+          </a:xfrm>
+          <a:prstGeom prst="rect">
+            <a:avLst/>
+          </a:prstGeom>
+          <a:noFill/>
+          <a:ln/>
+        </p:spPr>
+        <p:txBody>
+          <a:bodyPr wrap="square" lIns="0" tIns="0" rIns="0" bIns="0" rtlCol="0" anchor="ctr"/>
+          <a:lstStyle/>
+          <a:p>
+            <a:pPr algn="r" indent="0" marL="0">
+              <a:buNone/>
+            </a:pPr>
+            <a:r>
+              <a:rPr lang="en-US" sz="1000" dirty="0">
+                <a:solidFill>
+                  <a:srgbClr val="6B7280"/>
+                </a:solidFill>
+                <a:latin typeface="Calibri" pitchFamily="34" charset="0"/>
+                <a:ea typeface="Calibri" pitchFamily="34" charset="-122"/>
+                <a:cs typeface="Calibri" pitchFamily="34" charset="-120"/>
+              </a:rPr>
+              <a:t>Day 1 · Module 7</a:t>
+            </a:r>
+            <a:endParaRPr lang="en-US" sz="1000" dirty="0"/>
+          </a:p>
+        </p:txBody>
+      </p:sp>
+      <p:sp>
+        <p:nvSpPr>
+          <p:cNvPr id="4" name="Text 2"/>
+          <p:cNvSpPr/>
+          <p:nvPr/>
+        </p:nvSpPr>
+        <p:spPr>
+          <a:xfrm>
+            <a:off x="365760" y="320040"/>
+            <a:ext cx="6217920" cy="640080"/>
+          </a:xfrm>
+          <a:prstGeom prst="rect">
+            <a:avLst/>
+          </a:prstGeom>
+          <a:noFill/>
+          <a:ln/>
+        </p:spPr>
+        <p:txBody>
+          <a:bodyPr wrap="square" lIns="0" tIns="0" rIns="0" bIns="0" rtlCol="0" anchor="ctr"/>
+          <a:lstStyle/>
+          <a:p>
+            <a:pPr indent="0" marL="0">
+              <a:buNone/>
+            </a:pPr>
+            <a:r>
+              <a:rPr lang="en-US" sz="2800" b="1" dirty="0">
+                <a:solidFill>
+                  <a:srgbClr val="1E2761"/>
+                </a:solidFill>
+                <a:latin typeface="Calibri" pitchFamily="34" charset="0"/>
+                <a:ea typeface="Calibri" pitchFamily="34" charset="-122"/>
+                <a:cs typeface="Calibri" pitchFamily="34" charset="-120"/>
+              </a:rPr>
+              <a:t>Takeaways</a:t>
+            </a:r>
+            <a:endParaRPr lang="en-US" sz="2800" dirty="0"/>
+          </a:p>
+        </p:txBody>
+      </p:sp>
+      <p:sp>
+        <p:nvSpPr>
+          <p:cNvPr id="5" name="Text 3"/>
+          <p:cNvSpPr/>
+          <p:nvPr/>
+        </p:nvSpPr>
+        <p:spPr>
+          <a:xfrm>
+            <a:off x="365760" y="1097280"/>
+            <a:ext cx="8412480" cy="3108960"/>
+          </a:xfrm>
+          <a:prstGeom prst="rect">
+            <a:avLst/>
+          </a:prstGeom>
+          <a:noFill/>
+          <a:ln/>
+        </p:spPr>
+        <p:txBody>
+          <a:bodyPr wrap="square" rtlCol="0" anchor="ctr"/>
+          <a:lstStyle/>
+          <a:p>
+            <a:pPr marL="342900" indent="-342900">
+              <a:spcAft>
+                <a:spcPts val="600"/>
+              </a:spcAft>
+              <a:buSzPct val="100000"/>
+              <a:buChar char="•"/>
+            </a:pPr>
+            <a:r>
+              <a:rPr lang="en-US" sz="1500" dirty="0">
+                <a:solidFill>
+                  <a:srgbClr val="212121"/>
+                </a:solidFill>
+                <a:latin typeface="Calibri" pitchFamily="34" charset="0"/>
+                <a:ea typeface="Calibri" pitchFamily="34" charset="-122"/>
+                <a:cs typeface="Calibri" pitchFamily="34" charset="-120"/>
+              </a:rPr>
+              <a:t>Same underlying docs-assistant behavior — three hosting options with Foundry.</a:t>
+            </a:r>
+            <a:endParaRPr lang="en-US" sz="1500" dirty="0"/>
+          </a:p>
+          <a:p>
+            <a:pPr marL="342900" indent="-342900">
+              <a:spcAft>
+                <a:spcPts val="600"/>
+              </a:spcAft>
+              <a:buSzPct val="100000"/>
+              <a:buChar char="•"/>
+            </a:pPr>
+            <a:r>
+              <a:rPr lang="en-US" sz="1500" dirty="0">
+                <a:solidFill>
+                  <a:srgbClr val="212121"/>
+                </a:solidFill>
+                <a:latin typeface="Calibri" pitchFamily="34" charset="0"/>
+                <a:ea typeface="Calibri" pitchFamily="34" charset="-122"/>
+                <a:cs typeface="Calibri" pitchFamily="34" charset="-120"/>
+              </a:rPr>
+              <a:t>Focus on feeling the difference — not just making the code run.</a:t>
+            </a:r>
+            <a:endParaRPr lang="en-US" sz="1500" dirty="0"/>
+          </a:p>
+          <a:p>
+            <a:pPr marL="342900" indent="-342900">
+              <a:spcAft>
+                <a:spcPts val="600"/>
+              </a:spcAft>
+              <a:buSzPct val="100000"/>
+              <a:buChar char="•"/>
+            </a:pPr>
+            <a:r>
+              <a:rPr lang="en-US" sz="1500" dirty="0">
+                <a:solidFill>
+                  <a:srgbClr val="212121"/>
+                </a:solidFill>
+                <a:latin typeface="Calibri" pitchFamily="34" charset="0"/>
+                <a:ea typeface="Calibri" pitchFamily="34" charset="-122"/>
+                <a:cs typeface="Calibri" pitchFamily="34" charset="-120"/>
+              </a:rPr>
+              <a:t>The reflection is the deliverable, not the code.</a:t>
+            </a:r>
+            <a:endParaRPr lang="en-US" sz="1500" dirty="0"/>
+          </a:p>
+          <a:p>
+            <a:pPr marL="342900" indent="-342900">
+              <a:spcAft>
+                <a:spcPts val="600"/>
+              </a:spcAft>
+              <a:buSzPct val="100000"/>
+              <a:buChar char="•"/>
+            </a:pPr>
+            <a:r>
+              <a:rPr lang="en-US" sz="1500" dirty="0">
+                <a:solidFill>
+                  <a:srgbClr val="212121"/>
+                </a:solidFill>
+                <a:latin typeface="Calibri" pitchFamily="34" charset="0"/>
+                <a:ea typeface="Calibri" pitchFamily="34" charset="-122"/>
+                <a:cs typeface="Calibri" pitchFamily="34" charset="-120"/>
+              </a:rPr>
+              <a:t>Start noodling on your capstone scenario this week.</a:t>
+            </a:r>
+            <a:endParaRPr lang="en-US" sz="1500" dirty="0"/>
+          </a:p>
+        </p:txBody>
+      </p:sp>
+      <p:sp>
+        <p:nvSpPr>
+          <p:cNvPr id="6" name="Shape 4"/>
+          <p:cNvSpPr/>
+          <p:nvPr/>
+        </p:nvSpPr>
+        <p:spPr>
+          <a:xfrm>
+            <a:off x="365760" y="4343400"/>
+            <a:ext cx="8412480" cy="457200"/>
+          </a:xfrm>
+          <a:prstGeom prst="rect">
+            <a:avLst/>
+          </a:prstGeom>
+          <a:solidFill>
+            <a:srgbClr val="CADCFC"/>
+          </a:solidFill>
+          <a:ln/>
+        </p:spPr>
+      </p:sp>
+      <p:sp>
+        <p:nvSpPr>
+          <p:cNvPr id="7" name="Text 5"/>
+          <p:cNvSpPr/>
+          <p:nvPr/>
+        </p:nvSpPr>
+        <p:spPr>
+          <a:xfrm>
+            <a:off x="502920" y="4370832"/>
+            <a:ext cx="8138160" cy="402336"/>
+          </a:xfrm>
+          <a:prstGeom prst="rect">
+            <a:avLst/>
+          </a:prstGeom>
+          <a:noFill/>
+          <a:ln/>
+        </p:spPr>
+        <p:txBody>
+          <a:bodyPr wrap="square" lIns="0" tIns="0" rIns="0" bIns="0" rtlCol="0" anchor="ctr"/>
+          <a:lstStyle/>
+          <a:p>
+            <a:pPr indent="0" marL="0">
+              <a:buNone/>
+            </a:pPr>
+            <a:r>
+              <a:rPr lang="en-US" sz="1600" b="1" dirty="0">
+                <a:solidFill>
+                  <a:srgbClr val="1E2761"/>
+                </a:solidFill>
+                <a:latin typeface="Calibri" pitchFamily="34" charset="0"/>
+                <a:ea typeface="Calibri" pitchFamily="34" charset="-122"/>
+                <a:cs typeface="Calibri" pitchFamily="34" charset="-120"/>
+              </a:rPr>
+              <a:t>Next: </a:t>
+            </a:r>
+            <a:pPr indent="0" marL="0">
+              <a:buNone/>
+            </a:pPr>
+            <a:r>
+              <a:rPr lang="en-US" sz="1600" dirty="0">
+                <a:solidFill>
+                  <a:srgbClr val="1E2761"/>
+                </a:solidFill>
+                <a:latin typeface="Calibri" pitchFamily="34" charset="0"/>
+                <a:ea typeface="Calibri" pitchFamily="34" charset="-122"/>
+                <a:cs typeface="Calibri" pitchFamily="34" charset="-120"/>
+              </a:rPr>
+              <a:t>End of Day 1 live content. Have fun with the lab.</a:t>
+            </a:r>
+            <a:endParaRPr lang="en-US" sz="1600" dirty="0"/>
+          </a:p>
+        </p:txBody>
+      </p:sp>
+    </p:spTree>
+  </p:cSld>
+  <p:clrMapOvr>
+    <a:masterClrMapping/>
+  </p:clrMapOvr>
+</p:sld>
+</file>
+
 <file path=ppt/slides/slide2.xml><?xml version="1.0" encoding="utf-8"?>
 <p:sld xmlns:a="http://schemas.openxmlformats.org/drawingml/2006/main" xmlns:r="http://schemas.openxmlformats.org/officeDocument/2006/relationships" xmlns:p="http://schemas.openxmlformats.org/presentationml/2006/main">
   <p:cSld name="Slide 2">
@@ -4066,7 +4479,7 @@
                 <a:ea typeface="Calibri" pitchFamily="34" charset="-122"/>
                 <a:cs typeface="Calibri" pitchFamily="34" charset="-120"/>
               </a:rPr>
-              <a:t>Takeaways</a:t>
+              <a:t>Preview: your capstone project</a:t>
             </a:r>
             <a:endParaRPr lang="en-US" sz="2800" dirty="0"/>
           </a:p>
@@ -4081,7 +4494,124 @@
         <p:spPr>
           <a:xfrm>
             <a:off x="365760" y="1097280"/>
-            <a:ext cx="8412480" cy="3108960"/>
+            <a:ext cx="8412480" cy="548640"/>
+          </a:xfrm>
+          <a:prstGeom prst="rect">
+            <a:avLst/>
+          </a:prstGeom>
+          <a:noFill/>
+          <a:ln/>
+        </p:spPr>
+        <p:txBody>
+          <a:bodyPr wrap="square" rtlCol="0" anchor="ctr"/>
+          <a:lstStyle/>
+          <a:p>
+            <a:pPr indent="0" marL="0">
+              <a:buNone/>
+            </a:pPr>
+            <a:r>
+              <a:rPr lang="en-US" sz="1400" i="1" dirty="0">
+                <a:solidFill>
+                  <a:srgbClr val="212121"/>
+                </a:solidFill>
+                <a:latin typeface="Calibri" pitchFamily="34" charset="0"/>
+                <a:ea typeface="Calibri" pitchFamily="34" charset="-122"/>
+                <a:cs typeface="Calibri" pitchFamily="34" charset="-120"/>
+              </a:rPr>
+              <a:t>The workshop ends with a capstone. Start thinking about your scenario this week — every day gives you a piece.</a:t>
+            </a:r>
+            <a:endParaRPr lang="en-US" sz="1400" dirty="0"/>
+          </a:p>
+        </p:txBody>
+      </p:sp>
+      <p:sp>
+        <p:nvSpPr>
+          <p:cNvPr id="6" name="Text 4"/>
+          <p:cNvSpPr/>
+          <p:nvPr/>
+        </p:nvSpPr>
+        <p:spPr>
+          <a:xfrm>
+            <a:off x="365760" y="1691640"/>
+            <a:ext cx="4069080" cy="365760"/>
+          </a:xfrm>
+          <a:prstGeom prst="rect">
+            <a:avLst/>
+          </a:prstGeom>
+          <a:noFill/>
+          <a:ln/>
+        </p:spPr>
+        <p:txBody>
+          <a:bodyPr wrap="square" lIns="0" tIns="0" rIns="0" bIns="0" rtlCol="0" anchor="ctr"/>
+          <a:lstStyle/>
+          <a:p>
+            <a:pPr indent="0" marL="0">
+              <a:buNone/>
+            </a:pPr>
+            <a:r>
+              <a:rPr lang="en-US" sz="2000" b="1" dirty="0">
+                <a:solidFill>
+                  <a:srgbClr val="1E2761"/>
+                </a:solidFill>
+                <a:latin typeface="Calibri" pitchFamily="34" charset="0"/>
+                <a:ea typeface="Calibri" pitchFamily="34" charset="-122"/>
+                <a:cs typeface="Calibri" pitchFamily="34" charset="-120"/>
+              </a:rPr>
+              <a:t>The format</a:t>
+            </a:r>
+            <a:endParaRPr lang="en-US" sz="2000" dirty="0"/>
+          </a:p>
+        </p:txBody>
+      </p:sp>
+      <p:sp>
+        <p:nvSpPr>
+          <p:cNvPr id="7" name="Text 5"/>
+          <p:cNvSpPr/>
+          <p:nvPr/>
+        </p:nvSpPr>
+        <p:spPr>
+          <a:xfrm>
+            <a:off x="4709160" y="1691640"/>
+            <a:ext cx="4069080" cy="365760"/>
+          </a:xfrm>
+          <a:prstGeom prst="rect">
+            <a:avLst/>
+          </a:prstGeom>
+          <a:noFill/>
+          <a:ln/>
+        </p:spPr>
+        <p:txBody>
+          <a:bodyPr wrap="square" lIns="0" tIns="0" rIns="0" bIns="0" rtlCol="0" anchor="ctr"/>
+          <a:lstStyle/>
+          <a:p>
+            <a:pPr indent="0" marL="0">
+              <a:buNone/>
+            </a:pPr>
+            <a:r>
+              <a:rPr lang="en-US" sz="2000" b="1" dirty="0">
+                <a:solidFill>
+                  <a:srgbClr val="1E2761"/>
+                </a:solidFill>
+                <a:latin typeface="Calibri" pitchFamily="34" charset="0"/>
+                <a:ea typeface="Calibri" pitchFamily="34" charset="-122"/>
+                <a:cs typeface="Calibri" pitchFamily="34" charset="-120"/>
+              </a:rPr>
+              <a:t>Required elements (each day gives you a piece)</a:t>
+            </a:r>
+            <a:endParaRPr lang="en-US" sz="2000" dirty="0"/>
+          </a:p>
+        </p:txBody>
+      </p:sp>
+      <p:sp>
+        <p:nvSpPr>
+          <p:cNvPr id="8" name="Text 6"/>
+          <p:cNvSpPr/>
+          <p:nvPr/>
+        </p:nvSpPr>
+        <p:spPr>
+          <a:xfrm>
+            <a:off x="365760" y="2148840"/>
+            <a:ext cx="4069080" cy="2286000"/>
           </a:xfrm>
           <a:prstGeom prst="rect">
             <a:avLst/>
@@ -4109,7 +4639,7 @@
                 <a:ea typeface="Calibri" pitchFamily="34" charset="-122"/>
                 <a:cs typeface="Calibri" pitchFamily="34" charset="-120"/>
               </a:rPr>
-              <a:t>Same underlying docs-assistant behavior — three hosting options with Foundry.</a:t>
+              <a:t>Solo, or teams of 2–3</a:t>
             </a:r>
             <a:endParaRPr lang="en-US" sz="1500" dirty="0"/>
           </a:p>
@@ -4130,7 +4660,7 @@
                 <a:ea typeface="Calibri" pitchFamily="34" charset="-122"/>
                 <a:cs typeface="Calibri" pitchFamily="34" charset="-120"/>
               </a:rPr>
-              <a:t>Focus on feeling the difference — not just making the code run.</a:t>
+              <a:t>Starts at Day 5 close · target completion 4–6 weeks after</a:t>
             </a:r>
             <a:endParaRPr lang="en-US" sz="1500" dirty="0"/>
           </a:p>
@@ -4151,21 +4681,232 @@
                 <a:ea typeface="Calibri" pitchFamily="34" charset="-122"/>
                 <a:cs typeface="Calibri" pitchFamily="34" charset="-120"/>
               </a:rPr>
-              <a:t>The reflection is the deliverable, not the code.</a:t>
+              <a:t>1:1 architecture review with Jim (± Pradeep)</a:t>
             </a:r>
             <a:endParaRPr lang="en-US" sz="1500" dirty="0"/>
           </a:p>
-        </p:txBody>
-      </p:sp>
-      <p:sp>
-        <p:nvSpPr>
-          <p:cNvPr id="6" name="Shape 4"/>
-          <p:cNvSpPr/>
-          <p:nvPr/>
-        </p:nvSpPr>
-        <p:spPr>
-          <a:xfrm>
-            <a:off x="365760" y="4343400"/>
+          <a:p>
+            <a:pPr marL="342900" indent="-342900">
+              <a:spcAft>
+                <a:spcPts val="600"/>
+              </a:spcAft>
+              <a:buSzPct val="100000"/>
+              <a:buChar char="•"/>
+            </a:pPr>
+            <a:r>
+              <a:rPr lang="en-US" sz="1500" dirty="0">
+                <a:solidFill>
+                  <a:srgbClr val="212121"/>
+                </a:solidFill>
+                <a:latin typeface="Calibri" pitchFamily="34" charset="0"/>
+                <a:ea typeface="Calibri" pitchFamily="34" charset="-122"/>
+                <a:cs typeface="Calibri" pitchFamily="34" charset="-120"/>
+              </a:rPr>
+              <a:t>Coaching and feedback — no competitive scoring</a:t>
+            </a:r>
+            <a:endParaRPr lang="en-US" sz="1500" dirty="0"/>
+          </a:p>
+          <a:p>
+            <a:pPr marL="342900" indent="-342900">
+              <a:spcAft>
+                <a:spcPts val="600"/>
+              </a:spcAft>
+              <a:buSzPct val="100000"/>
+              <a:buChar char="•"/>
+            </a:pPr>
+            <a:r>
+              <a:rPr lang="en-US" sz="1500" dirty="0">
+                <a:solidFill>
+                  <a:srgbClr val="212121"/>
+                </a:solidFill>
+                <a:latin typeface="Calibri" pitchFamily="34" charset="0"/>
+                <a:ea typeface="Calibri" pitchFamily="34" charset="-122"/>
+                <a:cs typeface="Calibri" pitchFamily="34" charset="-120"/>
+              </a:rPr>
+              <a:t>Your choice of scenario</a:t>
+            </a:r>
+            <a:endParaRPr lang="en-US" sz="1500" dirty="0"/>
+          </a:p>
+        </p:txBody>
+      </p:sp>
+      <p:sp>
+        <p:nvSpPr>
+          <p:cNvPr id="9" name="Text 7"/>
+          <p:cNvSpPr/>
+          <p:nvPr/>
+        </p:nvSpPr>
+        <p:spPr>
+          <a:xfrm>
+            <a:off x="4709160" y="2148840"/>
+            <a:ext cx="4069080" cy="2286000"/>
+          </a:xfrm>
+          <a:prstGeom prst="rect">
+            <a:avLst/>
+          </a:prstGeom>
+          <a:noFill/>
+          <a:ln/>
+        </p:spPr>
+        <p:txBody>
+          <a:bodyPr wrap="square" rtlCol="0" anchor="ctr"/>
+          <a:lstStyle/>
+          <a:p>
+            <a:pPr marL="342900" indent="-342900">
+              <a:spcAft>
+                <a:spcPts val="600"/>
+              </a:spcAft>
+              <a:buSzPct val="100000"/>
+              <a:buChar char="•"/>
+            </a:pPr>
+            <a:r>
+              <a:rPr lang="en-US" sz="1500" dirty="0">
+                <a:solidFill>
+                  <a:srgbClr val="212121"/>
+                </a:solidFill>
+                <a:latin typeface="Calibri" pitchFamily="34" charset="0"/>
+                <a:ea typeface="Calibri" pitchFamily="34" charset="-122"/>
+                <a:cs typeface="Calibri" pitchFamily="34" charset="-120"/>
+              </a:rPr>
+              <a:t>An MAF agent (Prompt agent, Hosted agent, or Path C)</a:t>
+            </a:r>
+            <a:endParaRPr lang="en-US" sz="1500" dirty="0"/>
+          </a:p>
+          <a:p>
+            <a:pPr marL="342900" indent="-342900">
+              <a:spcAft>
+                <a:spcPts val="600"/>
+              </a:spcAft>
+              <a:buSzPct val="100000"/>
+              <a:buChar char="•"/>
+            </a:pPr>
+            <a:r>
+              <a:rPr lang="en-US" sz="1500" dirty="0">
+                <a:solidFill>
+                  <a:srgbClr val="212121"/>
+                </a:solidFill>
+                <a:latin typeface="Calibri" pitchFamily="34" charset="0"/>
+                <a:ea typeface="Calibri" pitchFamily="34" charset="-122"/>
+                <a:cs typeface="Calibri" pitchFamily="34" charset="-120"/>
+              </a:rPr>
+              <a:t>Grounded in a Foundry-deployed model</a:t>
+            </a:r>
+            <a:endParaRPr lang="en-US" sz="1500" dirty="0"/>
+          </a:p>
+          <a:p>
+            <a:pPr marL="342900" indent="-342900">
+              <a:spcAft>
+                <a:spcPts val="600"/>
+              </a:spcAft>
+              <a:buSzPct val="100000"/>
+              <a:buChar char="•"/>
+            </a:pPr>
+            <a:r>
+              <a:rPr lang="en-US" sz="1500" dirty="0">
+                <a:solidFill>
+                  <a:srgbClr val="212121"/>
+                </a:solidFill>
+                <a:latin typeface="Calibri" pitchFamily="34" charset="0"/>
+                <a:ea typeface="Calibri" pitchFamily="34" charset="-122"/>
+                <a:cs typeface="Calibri" pitchFamily="34" charset="-120"/>
+              </a:rPr>
+              <a:t>At least one Toolbox tool, MCP server, or function tool</a:t>
+            </a:r>
+            <a:endParaRPr lang="en-US" sz="1500" dirty="0"/>
+          </a:p>
+          <a:p>
+            <a:pPr marL="342900" indent="-342900">
+              <a:spcAft>
+                <a:spcPts val="600"/>
+              </a:spcAft>
+              <a:buSzPct val="100000"/>
+              <a:buChar char="•"/>
+            </a:pPr>
+            <a:r>
+              <a:rPr lang="en-US" sz="1500" dirty="0">
+                <a:solidFill>
+                  <a:srgbClr val="212121"/>
+                </a:solidFill>
+                <a:latin typeface="Calibri" pitchFamily="34" charset="0"/>
+                <a:ea typeface="Calibri" pitchFamily="34" charset="-122"/>
+                <a:cs typeface="Calibri" pitchFamily="34" charset="-120"/>
+              </a:rPr>
+              <a:t>At least one Foundry IQ source or custom RAG</a:t>
+            </a:r>
+            <a:endParaRPr lang="en-US" sz="1500" dirty="0"/>
+          </a:p>
+          <a:p>
+            <a:pPr marL="342900" indent="-342900">
+              <a:spcAft>
+                <a:spcPts val="600"/>
+              </a:spcAft>
+              <a:buSzPct val="100000"/>
+              <a:buChar char="•"/>
+            </a:pPr>
+            <a:r>
+              <a:rPr lang="en-US" sz="1500" dirty="0">
+                <a:solidFill>
+                  <a:srgbClr val="212121"/>
+                </a:solidFill>
+                <a:latin typeface="Calibri" pitchFamily="34" charset="0"/>
+                <a:ea typeface="Calibri" pitchFamily="34" charset="-122"/>
+                <a:cs typeface="Calibri" pitchFamily="34" charset="-120"/>
+              </a:rPr>
+              <a:t>A golden set of ≥10 items + captured eval score</a:t>
+            </a:r>
+            <a:endParaRPr lang="en-US" sz="1500" dirty="0"/>
+          </a:p>
+          <a:p>
+            <a:pPr marL="342900" indent="-342900">
+              <a:spcAft>
+                <a:spcPts val="600"/>
+              </a:spcAft>
+              <a:buSzPct val="100000"/>
+              <a:buChar char="•"/>
+            </a:pPr>
+            <a:r>
+              <a:rPr lang="en-US" sz="1500" dirty="0">
+                <a:solidFill>
+                  <a:srgbClr val="212121"/>
+                </a:solidFill>
+                <a:latin typeface="Calibri" pitchFamily="34" charset="0"/>
+                <a:ea typeface="Calibri" pitchFamily="34" charset="-122"/>
+                <a:cs typeface="Calibri" pitchFamily="34" charset="-120"/>
+              </a:rPr>
+              <a:t>OTel traces visible in the portal or App Insights</a:t>
+            </a:r>
+            <a:endParaRPr lang="en-US" sz="1500" dirty="0"/>
+          </a:p>
+          <a:p>
+            <a:pPr marL="342900" indent="-342900">
+              <a:spcAft>
+                <a:spcPts val="600"/>
+              </a:spcAft>
+              <a:buSzPct val="100000"/>
+              <a:buChar char="•"/>
+            </a:pPr>
+            <a:r>
+              <a:rPr lang="en-US" sz="1500" dirty="0">
+                <a:solidFill>
+                  <a:srgbClr val="212121"/>
+                </a:solidFill>
+                <a:latin typeface="Calibri" pitchFamily="34" charset="0"/>
+                <a:ea typeface="Calibri" pitchFamily="34" charset="-122"/>
+                <a:cs typeface="Calibri" pitchFamily="34" charset="-120"/>
+              </a:rPr>
+              <a:t>Architecture diagram + README with 30-day next steps</a:t>
+            </a:r>
+            <a:endParaRPr lang="en-US" sz="1500" dirty="0"/>
+          </a:p>
+        </p:txBody>
+      </p:sp>
+      <p:sp>
+        <p:nvSpPr>
+          <p:cNvPr id="10" name="Shape 8"/>
+          <p:cNvSpPr/>
+          <p:nvPr/>
+        </p:nvSpPr>
+        <p:spPr>
+          <a:xfrm>
+            <a:off x="365760" y="4526280"/>
             <a:ext cx="8412480" cy="457200"/>
           </a:xfrm>
           <a:prstGeom prst="rect">
@@ -4179,13 +4920,13 @@
       </p:sp>
       <p:sp>
         <p:nvSpPr>
-          <p:cNvPr id="7" name="Text 5"/>
-          <p:cNvSpPr/>
-          <p:nvPr/>
-        </p:nvSpPr>
-        <p:spPr>
-          <a:xfrm>
-            <a:off x="502920" y="4370832"/>
+          <p:cNvPr id="11" name="Text 9"/>
+          <p:cNvSpPr/>
+          <p:nvPr/>
+        </p:nvSpPr>
+        <p:spPr>
+          <a:xfrm>
+            <a:off x="502920" y="4553712"/>
             <a:ext cx="8138160" cy="402336"/>
           </a:xfrm>
           <a:prstGeom prst="rect">
@@ -4202,7 +4943,7 @@
               <a:buNone/>
             </a:pPr>
             <a:r>
-              <a:rPr lang="en-US" sz="1600" b="1" dirty="0">
+              <a:rPr lang="en-US" sz="1200" b="1" dirty="0">
                 <a:solidFill>
                   <a:srgbClr val="1E2761"/>
                 </a:solidFill>
@@ -4210,13 +4951,13 @@
                 <a:ea typeface="Calibri" pitchFamily="34" charset="-122"/>
                 <a:cs typeface="Calibri" pitchFamily="34" charset="-120"/>
               </a:rPr>
-              <a:t>Next: </a:t>
+              <a:t>Start today: </a:t>
             </a:r>
             <a:pPr indent="0" marL="0">
               <a:buNone/>
             </a:pPr>
             <a:r>
-              <a:rPr lang="en-US" sz="1600" dirty="0">
+              <a:rPr lang="en-US" sz="1200" dirty="0">
                 <a:solidFill>
                   <a:srgbClr val="1E2761"/>
                 </a:solidFill>
@@ -4224,9 +4965,9 @@
                 <a:ea typeface="Calibri" pitchFamily="34" charset="-122"/>
                 <a:cs typeface="Calibri" pitchFamily="34" charset="-120"/>
               </a:rPr>
-              <a:t>End of Day 1 live content. Have fun with the lab.</a:t>
-            </a:r>
-            <a:endParaRPr lang="en-US" sz="1600" dirty="0"/>
+              <a:t>reflection question #4 asks what you'd want to build next — that's your capstone starter.</a:t>
+            </a:r>
+            <a:endParaRPr lang="en-US" sz="1200" dirty="0"/>
           </a:p>
         </p:txBody>
       </p:sp>

</xml_diff>